<commit_message>
Implementazione logreg + plot di comparison
</commit_message>
<xml_diff>
--- a/docs/Medical Image Compression and Analysis presentazione.pptx
+++ b/docs/Medical Image Compression and Analysis presentazione.pptx
@@ -123,16 +123,40 @@
 </p:presentation>
 </file>
 
-<file path=ppt/revisionInfo.xml><?xml version="1.0" encoding="utf-8"?>
-<p1510:revInfo xmlns:a="http://schemas.openxmlformats.org/drawingml/2006/main" xmlns:r="http://schemas.openxmlformats.org/officeDocument/2006/relationships" xmlns:p1510="http://schemas.microsoft.com/office/powerpoint/2015/10/main">
-  <p1510:revLst>
-    <p1510:client id="{B59A7308-2726-483F-9D61-945DB33CCF43}" v="99" dt="2026-04-10T11:32:37.731"/>
-  </p1510:revLst>
-</p1510:revInfo>
-</file>
-
 <file path=ppt/changesInfos/changesInfo1.xml><?xml version="1.0" encoding="utf-8"?>
 <pc:chgInfo xmlns:a="http://schemas.openxmlformats.org/drawingml/2006/main" xmlns:r="http://schemas.openxmlformats.org/officeDocument/2006/relationships" xmlns:ac="http://schemas.microsoft.com/office/drawing/2013/main/command" xmlns:pc="http://schemas.microsoft.com/office/powerpoint/2013/main/command">
+  <pc:docChgLst>
+    <pc:chgData name="PATRUNO ANDREA" userId="434c2d3d-d760-4baf-8981-191d7218719d" providerId="ADAL" clId="{D49931E2-CE7A-4E79-93FA-3282CEFD0145}"/>
+    <pc:docChg chg="modSld">
+      <pc:chgData name="PATRUNO ANDREA" userId="434c2d3d-d760-4baf-8981-191d7218719d" providerId="ADAL" clId="{D49931E2-CE7A-4E79-93FA-3282CEFD0145}" dt="2026-04-12T10:22:37.564" v="1" actId="20577"/>
+      <pc:docMkLst>
+        <pc:docMk/>
+      </pc:docMkLst>
+      <pc:sldChg chg="modSp mod">
+        <pc:chgData name="PATRUNO ANDREA" userId="434c2d3d-d760-4baf-8981-191d7218719d" providerId="ADAL" clId="{D49931E2-CE7A-4E79-93FA-3282CEFD0145}" dt="2026-04-12T10:22:37.564" v="1" actId="20577"/>
+        <pc:sldMkLst>
+          <pc:docMk/>
+          <pc:sldMk cId="0" sldId="256"/>
+        </pc:sldMkLst>
+        <pc:spChg chg="mod">
+          <ac:chgData name="PATRUNO ANDREA" userId="434c2d3d-d760-4baf-8981-191d7218719d" providerId="ADAL" clId="{D49931E2-CE7A-4E79-93FA-3282CEFD0145}" dt="2026-04-12T10:22:35.332" v="0" actId="14100"/>
+          <ac:spMkLst>
+            <pc:docMk/>
+            <pc:sldMk cId="0" sldId="256"/>
+            <ac:spMk id="4" creationId="{00000000-0000-0000-0000-000000000000}"/>
+          </ac:spMkLst>
+        </pc:spChg>
+        <pc:spChg chg="mod">
+          <ac:chgData name="PATRUNO ANDREA" userId="434c2d3d-d760-4baf-8981-191d7218719d" providerId="ADAL" clId="{D49931E2-CE7A-4E79-93FA-3282CEFD0145}" dt="2026-04-12T10:22:37.564" v="1" actId="20577"/>
+          <ac:spMkLst>
+            <pc:docMk/>
+            <pc:sldMk cId="0" sldId="256"/>
+            <ac:spMk id="13" creationId="{00000000-0000-0000-0000-000000000000}"/>
+          </ac:spMkLst>
+        </pc:spChg>
+      </pc:sldChg>
+    </pc:docChg>
+  </pc:docChgLst>
   <pc:docChgLst>
     <pc:chgData name="PATRUNO ANDREA" userId="434c2d3d-d760-4baf-8981-191d7218719d" providerId="ADAL" clId="{16F693D4-62C4-4BA3-8943-81787A08A71E}"/>
     <pc:docChg chg="undo redo custSel addSld modSld sldOrd">
@@ -273,14 +297,6 @@
             <ac:spMk id="9" creationId="{00000000-0000-0000-0000-000000000000}"/>
           </ac:spMkLst>
         </pc:spChg>
-        <pc:spChg chg="del mod">
-          <ac:chgData name="PATRUNO ANDREA" userId="434c2d3d-d760-4baf-8981-191d7218719d" providerId="ADAL" clId="{16F693D4-62C4-4BA3-8943-81787A08A71E}" dt="2026-04-10T11:28:11.117" v="546" actId="478"/>
-          <ac:spMkLst>
-            <pc:docMk/>
-            <pc:sldMk cId="0" sldId="258"/>
-            <ac:spMk id="10" creationId="{00000000-0000-0000-0000-000000000000}"/>
-          </ac:spMkLst>
-        </pc:spChg>
         <pc:spChg chg="add del mod">
           <ac:chgData name="PATRUNO ANDREA" userId="434c2d3d-d760-4baf-8981-191d7218719d" providerId="ADAL" clId="{16F693D4-62C4-4BA3-8943-81787A08A71E}" dt="2026-04-10T11:37:57.038" v="674" actId="1076"/>
           <ac:spMkLst>
@@ -319,14 +335,6 @@
             <pc:docMk/>
             <pc:sldMk cId="0" sldId="258"/>
             <ac:spMk id="15" creationId="{00000000-0000-0000-0000-000000000000}"/>
-          </ac:spMkLst>
-        </pc:spChg>
-        <pc:spChg chg="del mod">
-          <ac:chgData name="PATRUNO ANDREA" userId="434c2d3d-d760-4baf-8981-191d7218719d" providerId="ADAL" clId="{16F693D4-62C4-4BA3-8943-81787A08A71E}" dt="2026-04-10T11:28:08.419" v="545" actId="478"/>
-          <ac:spMkLst>
-            <pc:docMk/>
-            <pc:sldMk cId="0" sldId="258"/>
-            <ac:spMk id="16" creationId="{00000000-0000-0000-0000-000000000000}"/>
           </ac:spMkLst>
         </pc:spChg>
         <pc:spChg chg="mod">
@@ -369,14 +377,6 @@
             <ac:spMk id="21" creationId="{00000000-0000-0000-0000-000000000000}"/>
           </ac:spMkLst>
         </pc:spChg>
-        <pc:spChg chg="del mod">
-          <ac:chgData name="PATRUNO ANDREA" userId="434c2d3d-d760-4baf-8981-191d7218719d" providerId="ADAL" clId="{16F693D4-62C4-4BA3-8943-81787A08A71E}" dt="2026-04-10T11:29:51.096" v="565" actId="478"/>
-          <ac:spMkLst>
-            <pc:docMk/>
-            <pc:sldMk cId="0" sldId="258"/>
-            <ac:spMk id="22" creationId="{00000000-0000-0000-0000-000000000000}"/>
-          </ac:spMkLst>
-        </pc:spChg>
         <pc:spChg chg="add del mod">
           <ac:chgData name="PATRUNO ANDREA" userId="434c2d3d-d760-4baf-8981-191d7218719d" providerId="ADAL" clId="{16F693D4-62C4-4BA3-8943-81787A08A71E}" dt="2026-04-10T11:37:15.731" v="663" actId="1076"/>
           <ac:spMkLst>
@@ -385,84 +385,12 @@
             <ac:spMk id="23" creationId="{00000000-0000-0000-0000-000000000000}"/>
           </ac:spMkLst>
         </pc:spChg>
-        <pc:spChg chg="del">
-          <ac:chgData name="PATRUNO ANDREA" userId="434c2d3d-d760-4baf-8981-191d7218719d" providerId="ADAL" clId="{16F693D4-62C4-4BA3-8943-81787A08A71E}" dt="2026-04-10T11:33:19.341" v="636" actId="478"/>
-          <ac:spMkLst>
-            <pc:docMk/>
-            <pc:sldMk cId="0" sldId="258"/>
-            <ac:spMk id="24" creationId="{00000000-0000-0000-0000-000000000000}"/>
-          </ac:spMkLst>
-        </pc:spChg>
-        <pc:spChg chg="del">
-          <ac:chgData name="PATRUNO ANDREA" userId="434c2d3d-d760-4baf-8981-191d7218719d" providerId="ADAL" clId="{16F693D4-62C4-4BA3-8943-81787A08A71E}" dt="2026-04-10T11:33:22.435" v="640" actId="478"/>
-          <ac:spMkLst>
-            <pc:docMk/>
-            <pc:sldMk cId="0" sldId="258"/>
-            <ac:spMk id="25" creationId="{00000000-0000-0000-0000-000000000000}"/>
-          </ac:spMkLst>
-        </pc:spChg>
-        <pc:spChg chg="add del mod">
-          <ac:chgData name="PATRUNO ANDREA" userId="434c2d3d-d760-4baf-8981-191d7218719d" providerId="ADAL" clId="{16F693D4-62C4-4BA3-8943-81787A08A71E}" dt="2026-04-10T11:33:25.155" v="641" actId="478"/>
-          <ac:spMkLst>
-            <pc:docMk/>
-            <pc:sldMk cId="0" sldId="258"/>
-            <ac:spMk id="26" creationId="{00000000-0000-0000-0000-000000000000}"/>
-          </ac:spMkLst>
-        </pc:spChg>
-        <pc:spChg chg="del mod">
-          <ac:chgData name="PATRUNO ANDREA" userId="434c2d3d-d760-4baf-8981-191d7218719d" providerId="ADAL" clId="{16F693D4-62C4-4BA3-8943-81787A08A71E}" dt="2026-04-10T11:33:59.853" v="646" actId="478"/>
-          <ac:spMkLst>
-            <pc:docMk/>
-            <pc:sldMk cId="0" sldId="258"/>
-            <ac:spMk id="27" creationId="{00000000-0000-0000-0000-000000000000}"/>
-          </ac:spMkLst>
-        </pc:spChg>
         <pc:spChg chg="mod">
           <ac:chgData name="PATRUNO ANDREA" userId="434c2d3d-d760-4baf-8981-191d7218719d" providerId="ADAL" clId="{16F693D4-62C4-4BA3-8943-81787A08A71E}" dt="2026-04-10T11:37:15.731" v="663" actId="1076"/>
           <ac:spMkLst>
             <pc:docMk/>
             <pc:sldMk cId="0" sldId="258"/>
             <ac:spMk id="28" creationId="{00000000-0000-0000-0000-000000000000}"/>
-          </ac:spMkLst>
-        </pc:spChg>
-        <pc:spChg chg="add del mod">
-          <ac:chgData name="PATRUNO ANDREA" userId="434c2d3d-d760-4baf-8981-191d7218719d" providerId="ADAL" clId="{16F693D4-62C4-4BA3-8943-81787A08A71E}" dt="2026-04-10T11:36:19.794" v="650" actId="478"/>
-          <ac:spMkLst>
-            <pc:docMk/>
-            <pc:sldMk cId="0" sldId="258"/>
-            <ac:spMk id="29" creationId="{00000000-0000-0000-0000-000000000000}"/>
-          </ac:spMkLst>
-        </pc:spChg>
-        <pc:spChg chg="add del">
-          <ac:chgData name="PATRUNO ANDREA" userId="434c2d3d-d760-4baf-8981-191d7218719d" providerId="ADAL" clId="{16F693D4-62C4-4BA3-8943-81787A08A71E}" dt="2026-04-10T11:36:24.588" v="654" actId="478"/>
-          <ac:spMkLst>
-            <pc:docMk/>
-            <pc:sldMk cId="0" sldId="258"/>
-            <ac:spMk id="30" creationId="{00000000-0000-0000-0000-000000000000}"/>
-          </ac:spMkLst>
-        </pc:spChg>
-        <pc:spChg chg="del">
-          <ac:chgData name="PATRUNO ANDREA" userId="434c2d3d-d760-4baf-8981-191d7218719d" providerId="ADAL" clId="{16F693D4-62C4-4BA3-8943-81787A08A71E}" dt="2026-04-10T11:36:21.586" v="651" actId="478"/>
-          <ac:spMkLst>
-            <pc:docMk/>
-            <pc:sldMk cId="0" sldId="258"/>
-            <ac:spMk id="31" creationId="{00000000-0000-0000-0000-000000000000}"/>
-          </ac:spMkLst>
-        </pc:spChg>
-        <pc:spChg chg="add del">
-          <ac:chgData name="PATRUNO ANDREA" userId="434c2d3d-d760-4baf-8981-191d7218719d" providerId="ADAL" clId="{16F693D4-62C4-4BA3-8943-81787A08A71E}" dt="2026-04-10T11:36:22.600" v="652" actId="478"/>
-          <ac:spMkLst>
-            <pc:docMk/>
-            <pc:sldMk cId="0" sldId="258"/>
-            <ac:spMk id="32" creationId="{00000000-0000-0000-0000-000000000000}"/>
-          </ac:spMkLst>
-        </pc:spChg>
-        <pc:spChg chg="del">
-          <ac:chgData name="PATRUNO ANDREA" userId="434c2d3d-d760-4baf-8981-191d7218719d" providerId="ADAL" clId="{16F693D4-62C4-4BA3-8943-81787A08A71E}" dt="2026-04-10T11:36:23.680" v="653" actId="478"/>
-          <ac:spMkLst>
-            <pc:docMk/>
-            <pc:sldMk cId="0" sldId="258"/>
-            <ac:spMk id="33" creationId="{00000000-0000-0000-0000-000000000000}"/>
           </ac:spMkLst>
         </pc:spChg>
         <pc:spChg chg="add mod">
@@ -474,27 +402,11 @@
           </ac:spMkLst>
         </pc:spChg>
         <pc:spChg chg="add mod">
-          <ac:chgData name="PATRUNO ANDREA" userId="434c2d3d-d760-4baf-8981-191d7218719d" providerId="ADAL" clId="{16F693D4-62C4-4BA3-8943-81787A08A71E}" dt="2026-04-10T11:15:17.180" v="425"/>
-          <ac:spMkLst>
-            <pc:docMk/>
-            <pc:sldMk cId="0" sldId="258"/>
-            <ac:spMk id="35" creationId="{6A59DCFB-316E-6DA6-3C3E-98DDA18DD9D6}"/>
-          </ac:spMkLst>
-        </pc:spChg>
-        <pc:spChg chg="add mod">
           <ac:chgData name="PATRUNO ANDREA" userId="434c2d3d-d760-4baf-8981-191d7218719d" providerId="ADAL" clId="{16F693D4-62C4-4BA3-8943-81787A08A71E}" dt="2026-04-10T11:37:28.922" v="664" actId="1076"/>
           <ac:spMkLst>
             <pc:docMk/>
             <pc:sldMk cId="0" sldId="258"/>
             <ac:spMk id="36" creationId="{60961725-D9AD-3387-4C49-2894430F26A9}"/>
-          </ac:spMkLst>
-        </pc:spChg>
-        <pc:spChg chg="add">
-          <ac:chgData name="PATRUNO ANDREA" userId="434c2d3d-d760-4baf-8981-191d7218719d" providerId="ADAL" clId="{16F693D4-62C4-4BA3-8943-81787A08A71E}" dt="2026-04-10T11:17:35.538" v="458"/>
-          <ac:spMkLst>
-            <pc:docMk/>
-            <pc:sldMk cId="0" sldId="258"/>
-            <ac:spMk id="37" creationId="{465AD13A-D365-460C-9E0C-0E5C72962A1B}"/>
           </ac:spMkLst>
         </pc:spChg>
         <pc:spChg chg="add mod">
@@ -503,70 +415,6 @@
             <pc:docMk/>
             <pc:sldMk cId="0" sldId="258"/>
             <ac:spMk id="38" creationId="{A16E7144-B6A9-C7F4-B894-81441A97DAF5}"/>
-          </ac:spMkLst>
-        </pc:spChg>
-        <pc:spChg chg="add del mod">
-          <ac:chgData name="PATRUNO ANDREA" userId="434c2d3d-d760-4baf-8981-191d7218719d" providerId="ADAL" clId="{16F693D4-62C4-4BA3-8943-81787A08A71E}" dt="2026-04-10T11:29:51.099" v="567"/>
-          <ac:spMkLst>
-            <pc:docMk/>
-            <pc:sldMk cId="0" sldId="258"/>
-            <ac:spMk id="39" creationId="{87482B08-D8CE-3447-27D5-F8352F4EEEF9}"/>
-          </ac:spMkLst>
-        </pc:spChg>
-        <pc:spChg chg="add">
-          <ac:chgData name="PATRUNO ANDREA" userId="434c2d3d-d760-4baf-8981-191d7218719d" providerId="ADAL" clId="{16F693D4-62C4-4BA3-8943-81787A08A71E}" dt="2026-04-10T11:32:03.034" v="602"/>
-          <ac:spMkLst>
-            <pc:docMk/>
-            <pc:sldMk cId="0" sldId="258"/>
-            <ac:spMk id="40" creationId="{229B02A0-0C5D-037A-C510-5DA0FC5CB75F}"/>
-          </ac:spMkLst>
-        </pc:spChg>
-        <pc:spChg chg="add">
-          <ac:chgData name="PATRUNO ANDREA" userId="434c2d3d-d760-4baf-8981-191d7218719d" providerId="ADAL" clId="{16F693D4-62C4-4BA3-8943-81787A08A71E}" dt="2026-04-10T11:32:05.498" v="603"/>
-          <ac:spMkLst>
-            <pc:docMk/>
-            <pc:sldMk cId="0" sldId="258"/>
-            <ac:spMk id="41" creationId="{9B7C7577-6878-2B83-2E40-87A4E987BB0F}"/>
-          </ac:spMkLst>
-        </pc:spChg>
-        <pc:spChg chg="add">
-          <ac:chgData name="PATRUNO ANDREA" userId="434c2d3d-d760-4baf-8981-191d7218719d" providerId="ADAL" clId="{16F693D4-62C4-4BA3-8943-81787A08A71E}" dt="2026-04-10T11:32:07.490" v="604"/>
-          <ac:spMkLst>
-            <pc:docMk/>
-            <pc:sldMk cId="0" sldId="258"/>
-            <ac:spMk id="42" creationId="{A369E701-1132-A46C-C0A8-7F1197CFD867}"/>
-          </ac:spMkLst>
-        </pc:spChg>
-        <pc:spChg chg="add">
-          <ac:chgData name="PATRUNO ANDREA" userId="434c2d3d-d760-4baf-8981-191d7218719d" providerId="ADAL" clId="{16F693D4-62C4-4BA3-8943-81787A08A71E}" dt="2026-04-10T11:32:12.351" v="605"/>
-          <ac:spMkLst>
-            <pc:docMk/>
-            <pc:sldMk cId="0" sldId="258"/>
-            <ac:spMk id="43" creationId="{5A28B202-A538-FA95-F31F-53E22BBA55D9}"/>
-          </ac:spMkLst>
-        </pc:spChg>
-        <pc:spChg chg="add">
-          <ac:chgData name="PATRUNO ANDREA" userId="434c2d3d-d760-4baf-8981-191d7218719d" providerId="ADAL" clId="{16F693D4-62C4-4BA3-8943-81787A08A71E}" dt="2026-04-10T11:32:13.752" v="606"/>
-          <ac:spMkLst>
-            <pc:docMk/>
-            <pc:sldMk cId="0" sldId="258"/>
-            <ac:spMk id="44" creationId="{869901E8-8FF2-7325-5AD6-E523136731C5}"/>
-          </ac:spMkLst>
-        </pc:spChg>
-        <pc:spChg chg="add">
-          <ac:chgData name="PATRUNO ANDREA" userId="434c2d3d-d760-4baf-8981-191d7218719d" providerId="ADAL" clId="{16F693D4-62C4-4BA3-8943-81787A08A71E}" dt="2026-04-10T11:32:25.894" v="609"/>
-          <ac:spMkLst>
-            <pc:docMk/>
-            <pc:sldMk cId="0" sldId="258"/>
-            <ac:spMk id="45" creationId="{ED414A47-8B57-E56E-654B-57789CB4B9EF}"/>
-          </ac:spMkLst>
-        </pc:spChg>
-        <pc:spChg chg="add del">
-          <ac:chgData name="PATRUNO ANDREA" userId="434c2d3d-d760-4baf-8981-191d7218719d" providerId="ADAL" clId="{16F693D4-62C4-4BA3-8943-81787A08A71E}" dt="2026-04-10T11:32:37.730" v="612" actId="478"/>
-          <ac:spMkLst>
-            <pc:docMk/>
-            <pc:sldMk cId="0" sldId="258"/>
-            <ac:spMk id="46" creationId="{152AE35B-23F3-8BE2-1E8F-CCA0F2B04B33}"/>
           </ac:spMkLst>
         </pc:spChg>
       </pc:sldChg>
@@ -772,62 +620,6 @@
             <ac:spMk id="4" creationId="{62B66494-BFC9-C502-95D6-0D93B9C4E241}"/>
           </ac:spMkLst>
         </pc:spChg>
-        <pc:spChg chg="add del mod">
-          <ac:chgData name="PATRUNO ANDREA" userId="434c2d3d-d760-4baf-8981-191d7218719d" providerId="ADAL" clId="{16F693D4-62C4-4BA3-8943-81787A08A71E}" dt="2026-04-10T10:56:45.438" v="117" actId="478"/>
-          <ac:spMkLst>
-            <pc:docMk/>
-            <pc:sldMk cId="2814612309" sldId="267"/>
-            <ac:spMk id="5" creationId="{7440FD3F-1609-BB1D-E30C-57DFFA739C21}"/>
-          </ac:spMkLst>
-        </pc:spChg>
-        <pc:spChg chg="add mod">
-          <ac:chgData name="PATRUNO ANDREA" userId="434c2d3d-d760-4baf-8981-191d7218719d" providerId="ADAL" clId="{16F693D4-62C4-4BA3-8943-81787A08A71E}" dt="2026-04-10T10:56:09.981" v="106"/>
-          <ac:spMkLst>
-            <pc:docMk/>
-            <pc:sldMk cId="2814612309" sldId="267"/>
-            <ac:spMk id="6" creationId="{2B57C4F8-781C-F05F-91F3-A629CF0964BE}"/>
-          </ac:spMkLst>
-        </pc:spChg>
-        <pc:spChg chg="add mod">
-          <ac:chgData name="PATRUNO ANDREA" userId="434c2d3d-d760-4baf-8981-191d7218719d" providerId="ADAL" clId="{16F693D4-62C4-4BA3-8943-81787A08A71E}" dt="2026-04-10T10:56:32.807" v="110" actId="571"/>
-          <ac:spMkLst>
-            <pc:docMk/>
-            <pc:sldMk cId="2814612309" sldId="267"/>
-            <ac:spMk id="7" creationId="{0043A703-93A7-2C9A-FFFC-B46FBFADCC76}"/>
-          </ac:spMkLst>
-        </pc:spChg>
-        <pc:spChg chg="add mod">
-          <ac:chgData name="PATRUNO ANDREA" userId="434c2d3d-d760-4baf-8981-191d7218719d" providerId="ADAL" clId="{16F693D4-62C4-4BA3-8943-81787A08A71E}" dt="2026-04-10T10:56:35.614" v="113"/>
-          <ac:spMkLst>
-            <pc:docMk/>
-            <pc:sldMk cId="2814612309" sldId="267"/>
-            <ac:spMk id="8" creationId="{A3EDF986-0AE5-8DC4-87FE-4105037DE6C6}"/>
-          </ac:spMkLst>
-        </pc:spChg>
-        <pc:spChg chg="add del mod">
-          <ac:chgData name="PATRUNO ANDREA" userId="434c2d3d-d760-4baf-8981-191d7218719d" providerId="ADAL" clId="{16F693D4-62C4-4BA3-8943-81787A08A71E}" dt="2026-04-10T10:58:29.561" v="151" actId="478"/>
-          <ac:spMkLst>
-            <pc:docMk/>
-            <pc:sldMk cId="2814612309" sldId="267"/>
-            <ac:spMk id="9" creationId="{55CBEB97-068C-D595-E24D-5201733600DC}"/>
-          </ac:spMkLst>
-        </pc:spChg>
-        <pc:spChg chg="add del">
-          <ac:chgData name="PATRUNO ANDREA" userId="434c2d3d-d760-4baf-8981-191d7218719d" providerId="ADAL" clId="{16F693D4-62C4-4BA3-8943-81787A08A71E}" dt="2026-04-10T10:57:49.147" v="124" actId="478"/>
-          <ac:spMkLst>
-            <pc:docMk/>
-            <pc:sldMk cId="2814612309" sldId="267"/>
-            <ac:spMk id="10" creationId="{45BEFC92-A9B9-E2FD-DDE4-6B24CF3FCD17}"/>
-          </ac:spMkLst>
-        </pc:spChg>
-        <pc:spChg chg="add del mod">
-          <ac:chgData name="PATRUNO ANDREA" userId="434c2d3d-d760-4baf-8981-191d7218719d" providerId="ADAL" clId="{16F693D4-62C4-4BA3-8943-81787A08A71E}" dt="2026-04-10T10:57:22.929" v="121" actId="478"/>
-          <ac:spMkLst>
-            <pc:docMk/>
-            <pc:sldMk cId="2814612309" sldId="267"/>
-            <ac:spMk id="11" creationId="{8BF04EE8-F885-7114-00B7-47B99DACB2A7}"/>
-          </ac:spMkLst>
-        </pc:spChg>
         <pc:spChg chg="add mod">
           <ac:chgData name="PATRUNO ANDREA" userId="434c2d3d-d760-4baf-8981-191d7218719d" providerId="ADAL" clId="{16F693D4-62C4-4BA3-8943-81787A08A71E}" dt="2026-04-10T11:08:44.904" v="374" actId="1076"/>
           <ac:spMkLst>
@@ -850,62 +642,6 @@
             <pc:docMk/>
             <pc:sldMk cId="2814612309" sldId="267"/>
             <ac:spMk id="14" creationId="{5FCE51B8-8F77-6AE8-D16E-DC115EED7138}"/>
-          </ac:spMkLst>
-        </pc:spChg>
-        <pc:spChg chg="del mod">
-          <ac:chgData name="PATRUNO ANDREA" userId="434c2d3d-d760-4baf-8981-191d7218719d" providerId="ADAL" clId="{16F693D4-62C4-4BA3-8943-81787A08A71E}" dt="2026-04-10T10:58:57.251" v="174" actId="478"/>
-          <ac:spMkLst>
-            <pc:docMk/>
-            <pc:sldMk cId="2814612309" sldId="267"/>
-            <ac:spMk id="15" creationId="{014C077E-91E8-1DA3-1F5A-B901E022F085}"/>
-          </ac:spMkLst>
-        </pc:spChg>
-        <pc:spChg chg="del">
-          <ac:chgData name="PATRUNO ANDREA" userId="434c2d3d-d760-4baf-8981-191d7218719d" providerId="ADAL" clId="{16F693D4-62C4-4BA3-8943-81787A08A71E}" dt="2026-04-10T10:58:51.287" v="169" actId="478"/>
-          <ac:spMkLst>
-            <pc:docMk/>
-            <pc:sldMk cId="2814612309" sldId="267"/>
-            <ac:spMk id="16" creationId="{032BD19B-A0F6-BC93-496D-492BB29C72BA}"/>
-          </ac:spMkLst>
-        </pc:spChg>
-        <pc:spChg chg="add del mod">
-          <ac:chgData name="PATRUNO ANDREA" userId="434c2d3d-d760-4baf-8981-191d7218719d" providerId="ADAL" clId="{16F693D4-62C4-4BA3-8943-81787A08A71E}" dt="2026-04-10T10:58:56.044" v="172" actId="478"/>
-          <ac:spMkLst>
-            <pc:docMk/>
-            <pc:sldMk cId="2814612309" sldId="267"/>
-            <ac:spMk id="17" creationId="{4CB6946B-72FC-F8C0-289A-FF90C0894FAF}"/>
-          </ac:spMkLst>
-        </pc:spChg>
-        <pc:spChg chg="del">
-          <ac:chgData name="PATRUNO ANDREA" userId="434c2d3d-d760-4baf-8981-191d7218719d" providerId="ADAL" clId="{16F693D4-62C4-4BA3-8943-81787A08A71E}" dt="2026-04-10T10:58:52.621" v="170" actId="478"/>
-          <ac:spMkLst>
-            <pc:docMk/>
-            <pc:sldMk cId="2814612309" sldId="267"/>
-            <ac:spMk id="18" creationId="{8718275E-0B49-F9BB-9B66-01447D062E1A}"/>
-          </ac:spMkLst>
-        </pc:spChg>
-        <pc:spChg chg="del">
-          <ac:chgData name="PATRUNO ANDREA" userId="434c2d3d-d760-4baf-8981-191d7218719d" providerId="ADAL" clId="{16F693D4-62C4-4BA3-8943-81787A08A71E}" dt="2026-04-10T10:58:42.903" v="166" actId="478"/>
-          <ac:spMkLst>
-            <pc:docMk/>
-            <pc:sldMk cId="2814612309" sldId="267"/>
-            <ac:spMk id="19" creationId="{316E6D0F-DB04-77D2-2AFB-8C86019CF8A5}"/>
-          </ac:spMkLst>
-        </pc:spChg>
-        <pc:spChg chg="add del mod">
-          <ac:chgData name="PATRUNO ANDREA" userId="434c2d3d-d760-4baf-8981-191d7218719d" providerId="ADAL" clId="{16F693D4-62C4-4BA3-8943-81787A08A71E}" dt="2026-04-10T10:58:54.865" v="171" actId="478"/>
-          <ac:spMkLst>
-            <pc:docMk/>
-            <pc:sldMk cId="2814612309" sldId="267"/>
-            <ac:spMk id="20" creationId="{C8BD0B53-069E-8DF7-6188-B91467E15BF0}"/>
-          </ac:spMkLst>
-        </pc:spChg>
-        <pc:spChg chg="add del mod">
-          <ac:chgData name="PATRUNO ANDREA" userId="434c2d3d-d760-4baf-8981-191d7218719d" providerId="ADAL" clId="{16F693D4-62C4-4BA3-8943-81787A08A71E}" dt="2026-04-10T10:58:41.794" v="165" actId="478"/>
-          <ac:spMkLst>
-            <pc:docMk/>
-            <pc:sldMk cId="2814612309" sldId="267"/>
-            <ac:spMk id="21" creationId="{9ACA4160-DBF5-C05D-8B6A-CE8C04587E00}"/>
           </ac:spMkLst>
         </pc:spChg>
         <pc:spChg chg="mod">
@@ -949,62 +685,6 @@
           </ac:spMkLst>
         </pc:spChg>
         <pc:spChg chg="add del mod">
-          <ac:chgData name="PATRUNO ANDREA" userId="434c2d3d-d760-4baf-8981-191d7218719d" providerId="ADAL" clId="{16F693D4-62C4-4BA3-8943-81787A08A71E}" dt="2026-04-10T11:04:29.122" v="302" actId="478"/>
-          <ac:spMkLst>
-            <pc:docMk/>
-            <pc:sldMk cId="2814612309" sldId="267"/>
-            <ac:spMk id="27" creationId="{06CBBFC5-9990-3F1B-CCCB-2D93EA1DA467}"/>
-          </ac:spMkLst>
-        </pc:spChg>
-        <pc:spChg chg="add del mod">
-          <ac:chgData name="PATRUNO ANDREA" userId="434c2d3d-d760-4baf-8981-191d7218719d" providerId="ADAL" clId="{16F693D4-62C4-4BA3-8943-81787A08A71E}" dt="2026-04-10T11:04:01.177" v="293" actId="478"/>
-          <ac:spMkLst>
-            <pc:docMk/>
-            <pc:sldMk cId="2814612309" sldId="267"/>
-            <ac:spMk id="28" creationId="{8BCD5FD6-6F21-5820-0853-B2F2BA07C385}"/>
-          </ac:spMkLst>
-        </pc:spChg>
-        <pc:spChg chg="add del mod">
-          <ac:chgData name="PATRUNO ANDREA" userId="434c2d3d-d760-4baf-8981-191d7218719d" providerId="ADAL" clId="{16F693D4-62C4-4BA3-8943-81787A08A71E}" dt="2026-04-10T11:03:59.816" v="292" actId="478"/>
-          <ac:spMkLst>
-            <pc:docMk/>
-            <pc:sldMk cId="2814612309" sldId="267"/>
-            <ac:spMk id="29" creationId="{FF6206B7-41E7-374C-4720-DD9DE9F9CEB6}"/>
-          </ac:spMkLst>
-        </pc:spChg>
-        <pc:spChg chg="del">
-          <ac:chgData name="PATRUNO ANDREA" userId="434c2d3d-d760-4baf-8981-191d7218719d" providerId="ADAL" clId="{16F693D4-62C4-4BA3-8943-81787A08A71E}" dt="2026-04-10T11:04:02.521" v="294" actId="478"/>
-          <ac:spMkLst>
-            <pc:docMk/>
-            <pc:sldMk cId="2814612309" sldId="267"/>
-            <ac:spMk id="30" creationId="{FC0062FF-1470-C534-8C80-3A4B95C49FD6}"/>
-          </ac:spMkLst>
-        </pc:spChg>
-        <pc:spChg chg="del mod">
-          <ac:chgData name="PATRUNO ANDREA" userId="434c2d3d-d760-4baf-8981-191d7218719d" providerId="ADAL" clId="{16F693D4-62C4-4BA3-8943-81787A08A71E}" dt="2026-04-10T11:04:03.548" v="295" actId="478"/>
-          <ac:spMkLst>
-            <pc:docMk/>
-            <pc:sldMk cId="2814612309" sldId="267"/>
-            <ac:spMk id="31" creationId="{37F0E15E-15ED-48F4-E292-2B7EB9F4FCEF}"/>
-          </ac:spMkLst>
-        </pc:spChg>
-        <pc:spChg chg="del">
-          <ac:chgData name="PATRUNO ANDREA" userId="434c2d3d-d760-4baf-8981-191d7218719d" providerId="ADAL" clId="{16F693D4-62C4-4BA3-8943-81787A08A71E}" dt="2026-04-10T11:04:04.881" v="296" actId="478"/>
-          <ac:spMkLst>
-            <pc:docMk/>
-            <pc:sldMk cId="2814612309" sldId="267"/>
-            <ac:spMk id="32" creationId="{A7B9CAD2-3F33-E442-44D2-EC47ABC7FB8A}"/>
-          </ac:spMkLst>
-        </pc:spChg>
-        <pc:spChg chg="del">
-          <ac:chgData name="PATRUNO ANDREA" userId="434c2d3d-d760-4baf-8981-191d7218719d" providerId="ADAL" clId="{16F693D4-62C4-4BA3-8943-81787A08A71E}" dt="2026-04-10T11:04:07.010" v="297" actId="478"/>
-          <ac:spMkLst>
-            <pc:docMk/>
-            <pc:sldMk cId="2814612309" sldId="267"/>
-            <ac:spMk id="33" creationId="{9DCE8435-6A48-5FA1-97DE-EADC6A344416}"/>
-          </ac:spMkLst>
-        </pc:spChg>
-        <pc:spChg chg="add del mod">
           <ac:chgData name="PATRUNO ANDREA" userId="434c2d3d-d760-4baf-8981-191d7218719d" providerId="ADAL" clId="{16F693D4-62C4-4BA3-8943-81787A08A71E}" dt="2026-04-10T11:08:44.904" v="374" actId="1076"/>
           <ac:spMkLst>
             <pc:docMk/>
@@ -1018,22 +698,6 @@
             <pc:docMk/>
             <pc:sldMk cId="2814612309" sldId="267"/>
             <ac:spMk id="36" creationId="{981C6F95-42A6-9117-4153-7A82AD31A77B}"/>
-          </ac:spMkLst>
-        </pc:spChg>
-        <pc:spChg chg="add mod">
-          <ac:chgData name="PATRUNO ANDREA" userId="434c2d3d-d760-4baf-8981-191d7218719d" providerId="ADAL" clId="{16F693D4-62C4-4BA3-8943-81787A08A71E}" dt="2026-04-10T11:01:10.666" v="227"/>
-          <ac:spMkLst>
-            <pc:docMk/>
-            <pc:sldMk cId="2814612309" sldId="267"/>
-            <ac:spMk id="37" creationId="{4322B502-070F-D80F-0001-D7CB2311B221}"/>
-          </ac:spMkLst>
-        </pc:spChg>
-        <pc:spChg chg="add del mod">
-          <ac:chgData name="PATRUNO ANDREA" userId="434c2d3d-d760-4baf-8981-191d7218719d" providerId="ADAL" clId="{16F693D4-62C4-4BA3-8943-81787A08A71E}" dt="2026-04-10T11:06:57.269" v="350" actId="478"/>
-          <ac:spMkLst>
-            <pc:docMk/>
-            <pc:sldMk cId="2814612309" sldId="267"/>
-            <ac:spMk id="38" creationId="{D3361295-B1E8-6C8B-2732-F1B2F4B92173}"/>
           </ac:spMkLst>
         </pc:spChg>
         <pc:spChg chg="add mod">
@@ -2493,7 +2157,7 @@
         <p:spPr>
           <a:xfrm>
             <a:off x="3492304" y="609922"/>
-            <a:ext cx="2665828" cy="432670"/>
+            <a:ext cx="2399045" cy="418192"/>
           </a:xfrm>
           <a:prstGeom prst="rect">
             <a:avLst/>
@@ -2739,18 +2403,7 @@
                 <a:ea typeface="Calibri" pitchFamily="34" charset="-122"/>
                 <a:cs typeface="Calibri" pitchFamily="34" charset="-120"/>
               </a:rPr>
-              <a:t>Andrea Patruno, Ivan </a:t>
-            </a:r>
-            <a:r>
-              <a:rPr lang="en-US" sz="1200" dirty="0" err="1">
-                <a:solidFill>
-                  <a:srgbClr val="FFFFFF"/>
-                </a:solidFill>
-                <a:latin typeface="Calibri" pitchFamily="34" charset="0"/>
-                <a:ea typeface="Calibri" pitchFamily="34" charset="-122"/>
-                <a:cs typeface="Calibri" pitchFamily="34" charset="-120"/>
-              </a:rPr>
-              <a:t>GiacomoColella</a:t>
+              <a:t>Andrea Patruno, Ivan Giacomo Colella</a:t>
             </a:r>
             <a:endParaRPr lang="en-US" sz="1200" dirty="0"/>
           </a:p>

</xml_diff>